<commit_message>
docs: synchronize technical documentation and competition desktop materials
- Synchronize docs/ARCHITECTURE.md with Teammate Mailbox, Hierarchical Memory, BDS escort, 60fps gesture isolation, role separation, and Docker.
- Update docs/API.md with BDS escort endpoints and Teammate Mailbox SSE events.
- Update docs/DESIGN.md with 60fps Leaflet gesture isolation & elder/child UI separation.
- Update docs/PRD.md and docs/APP_DEPLOY_AND_USER_GUIDE.md with Docker Compose deployment.
- Update 05_COMPETITION_VIDEO_STORYBOARD.md with accurate elder/child roles and technical highlights.
- Regenerate Word proposal report (.docx) without competition text, highlighting technical features.
- Regenerate 18-slide presentation deck (.pptx) with Teammate Mailbox, BDS RTK, 147 tests, and Docker.
- Synchronize all 4 competition preparation materials directly on Desktop.
</commit_message>
<xml_diff>
--- a/docs/competition/银发导航智能体：基于多Agent协同的老年人安心出行伴侣_作品介绍PPT.pptx
+++ b/docs/competition/银发导航智能体：基于多Agent协同的老年人安心出行伴侣_作品介绍PPT.pptx
@@ -4214,7 +4214,7 @@
               </a:defRPr>
             </a:pPr>
             <a:r>
-              <a:t>纵深三层守护：北斗高精动态安全走廊与异常滞留预警</a:t>
+              <a:t>纵深三层守护与双端分离：长辈极简实景导航 vs 子女安心守护大屏</a:t>
             </a:r>
           </a:p>
         </p:txBody>
@@ -4306,7 +4306,7 @@
                 </a:solidFill>
                 <a:latin typeface="Microsoft YaHei"/>
               </a:rPr>
-              <a:t>第一层：500-1500m 常住生活圈围栏：</a:t>
+              <a:t>长辈端（route-map.vue）：极简步道实景导航：</a:t>
             </a:r>
             <a:r>
               <a:rPr sz="1050">
@@ -4315,7 +4315,7 @@
                 </a:solidFill>
                 <a:latin typeface="Microsoft YaHei"/>
               </a:rPr>
-              <a:t>长辈日常在小区内活动不产生打扰式告警；离开生活圈时子女端进入柔性“关注态”。</a:t>
+              <a:t>杜绝复杂按钮，仅保留步道沿线、地标大卡片、慢速语音播报与『🕊️ 一键给家人报平安』，防迷路不添扰。</a:t>
             </a:r>
           </a:p>
           <a:p>
@@ -4339,7 +4339,7 @@
                 </a:solidFill>
                 <a:latin typeface="Microsoft YaHei"/>
               </a:rPr>
-              <a:t>第二层：50-80m 航迹动态安全微走廊：</a:t>
+              <a:t>子女端（guardian.vue）：数字孪生高精大屏：</a:t>
             </a:r>
             <a:r>
               <a:rPr sz="1050">
@@ -4348,7 +4348,7 @@
                 </a:solidFill>
                 <a:latin typeface="Microsoft YaHei"/>
               </a:rPr>
-              <a:t>沿规划步道构建动态缓冲区。一旦偏航连续2周期，向老人温和语音纠偏，子女端提示微偏航。</a:t>
+              <a:t>汇聚19颗北斗卫星高精度遥测指标（$BDGGA）、CGCS2000坐标轨迹、航向与步速，实现毫秒级远程护航。</a:t>
             </a:r>
           </a:p>
           <a:p>
@@ -4372,7 +4372,7 @@
                 </a:solidFill>
                 <a:latin typeface="Microsoft YaHei"/>
               </a:rPr>
-              <a:t>第三层：长椅智能甄别与异常滞留告警：</a:t>
+              <a:t>高精动态安全微走廊与异常滞留：</a:t>
             </a:r>
             <a:r>
               <a:rPr sz="1050">
@@ -4381,7 +4381,7 @@
                 </a:solidFill>
                 <a:latin typeface="Microsoft YaHei"/>
               </a:rPr>
-              <a:t>长椅/凉亭静止识别为休整，自动抑制误报；若在偏僻无设施路段静止超15分钟，秒级触发高危预警。</a:t>
+              <a:t>沿路线自动生成50-80m安全走廊；长椅休整自动豁免，偏僻路段滞留超限自动触发声光告警。</a:t>
             </a:r>
           </a:p>
           <a:p>
@@ -4405,7 +4405,7 @@
                 </a:solidFill>
                 <a:latin typeface="Microsoft YaHei"/>
               </a:rPr>
-              <a:t>一键报平安与双向亲情互动：</a:t>
+              <a:t>快捷亲情双向守护动作：</a:t>
             </a:r>
             <a:r>
               <a:rPr sz="1050">
@@ -4414,7 +4414,7 @@
                 </a:solidFill>
                 <a:latin typeface="Microsoft YaHei"/>
               </a:rPr>
-              <a:t>长辈到达公园点击报平安，子女端即刻收到带有北斗精准时空签章的平安卡片。</a:t>
+              <a:t>子女端提供『📞 一键致电长辈』与『💬 发送安心关怀』，与长辈端一键报平安形成温暖双向闭环。</a:t>
             </a:r>
           </a:p>
         </p:txBody>
@@ -4511,7 +4511,7 @@
               </a:defRPr>
             </a:pPr>
             <a:r>
-              <a:t>【请在此插入：子女端安全大屏 guardian.vue 电子围栏绘制与轨迹监控截图】</a:t>
+              <a:t>【请在此插入：老人端极简导航 vs 子女端守护大屏双端界面实机对比截图】</a:t>
             </a:r>
           </a:p>
         </p:txBody>
@@ -5795,7 +5795,7 @@
               </a:defRPr>
             </a:pPr>
             <a:r>
-              <a:t>严苛工程检验：146项全绿自动化测试与性能指标</a:t>
+              <a:t>严苛工程检验：147项全绿自动化测试与Docker容器化微服务</a:t>
             </a:r>
           </a:p>
         </p:txBody>
@@ -5876,7 +5876,7 @@
               </a:defRPr>
             </a:pPr>
             <a:r>
-              <a:t>146 </a:t>
+              <a:t>147 </a:t>
             </a:r>
             <a:r>
               <a:rPr sz="1300" b="1">
@@ -5901,7 +5901,7 @@
               </a:defRPr>
             </a:pPr>
             <a:r>
-              <a:t>全覆盖自动化测试套件 100% 通过 (12.35s)</a:t>
+              <a:t>自动化测试套件 100% 通过 (8.87s 全绿)</a:t>
             </a:r>
           </a:p>
         </p:txBody>
@@ -5982,7 +5982,7 @@
               </a:defRPr>
             </a:pPr>
             <a:r>
-              <a:t>&lt; 200 </a:t>
+              <a:t>Docker </a:t>
             </a:r>
             <a:r>
               <a:rPr sz="1300" b="1">
@@ -5991,7 +5991,7 @@
                 </a:solidFill>
                 <a:latin typeface="Microsoft YaHei"/>
               </a:rPr>
-              <a:t>ms</a:t>
+              <a:t>一键部署</a:t>
             </a:r>
           </a:p>
           <a:p>
@@ -6007,7 +6007,7 @@
               </a:defRPr>
             </a:pPr>
             <a:r>
-              <a:t>核心北斗与适老微地形API接口平均响应时延</a:t>
+              <a:t>前后端双容器编排隔离，docker compose一键启动</a:t>
             </a:r>
           </a:p>
         </p:txBody>
@@ -6088,7 +6088,7 @@
               </a:defRPr>
             </a:pPr>
             <a:r>
-              <a:t>1.2 </a:t>
+              <a:t>&lt; 200 </a:t>
             </a:r>
             <a:r>
               <a:rPr sz="1300" b="1">
@@ -6097,7 +6097,7 @@
                 </a:solidFill>
                 <a:latin typeface="Microsoft YaHei"/>
               </a:rPr>
-              <a:t>秒</a:t>
+              <a:t>ms</a:t>
             </a:r>
           </a:p>
           <a:p>
@@ -6113,7 +6113,7 @@
               </a:defRPr>
             </a:pPr>
             <a:r>
-              <a:t>5大Agent并发端到端推理与方案装配全耗时</a:t>
+              <a:t>核心北斗与适老微地形API高并发平均响应</a:t>
             </a:r>
           </a:p>
         </p:txBody>
@@ -6214,7 +6214,7 @@
                 </a:solidFill>
                 <a:latin typeface="Microsoft YaHei"/>
               </a:rPr>
-              <a:t>覆盖12项高斯坐标极限漂移、复杂凹多边形电子围栏穿透碰撞、弱网丢包自愈用例。</a:t>
+              <a:t>覆盖高斯坐标极限漂移、复杂凹多边形电子围栏穿透碰撞、弱网丢包自愈等高对抗用例。</a:t>
             </a:r>
           </a:p>
           <a:p>
@@ -6238,7 +6238,7 @@
                 </a:solidFill>
                 <a:latin typeface="Microsoft YaHei"/>
               </a:rPr>
-              <a:t>多Agent并发死锁防护：</a:t>
+              <a:t>多Agent信箱并发死锁防护：</a:t>
             </a:r>
             <a:r>
               <a:rPr sz="1050">
@@ -6247,7 +6247,7 @@
                 </a:solidFill>
                 <a:latin typeface="Microsoft YaHei"/>
               </a:rPr>
-              <a:t>微内核全序事件契约，高并发压力下零死锁、零竞态、单轮闭环率 100%。</a:t>
+              <a:t>微内核全序事件总线与Teammate Mailbox，高并发下零死锁、零竞态、单轮闭环率 100%。</a:t>
             </a:r>
           </a:p>
           <a:p>
@@ -6271,7 +6271,7 @@
                 </a:solidFill>
                 <a:latin typeface="Microsoft YaHei"/>
               </a:rPr>
-              <a:t>急救熔断与故障隔离：</a:t>
+              <a:t>容器化开箱即用体验：</a:t>
             </a:r>
             <a:r>
               <a:rPr sz="1050">
@@ -6280,7 +6280,7 @@
                 </a:solidFill>
                 <a:latin typeface="Microsoft YaHei"/>
               </a:rPr>
-              <a:t>模拟气象接口断网或大模型波动，系统毫秒级降级为本地离线微地形规则，保障导航不掉线。</a:t>
+              <a:t>提供标准 Dockerfile 与 docker-compose.yml，搭配一键启动脚本，脱离环境差异束缚。</a:t>
             </a:r>
           </a:p>
           <a:p>
@@ -6313,7 +6313,7 @@
                 </a:solidFill>
                 <a:latin typeface="Microsoft YaHei"/>
               </a:rPr>
-              <a:t>完备的测试驱动工程实践，具备冲击国家级一等奖的软件工业级品质。</a:t>
+              <a:t>测试驱动与容器化最佳实践，验证了系统具备工业级工程成熟度与可靠性。</a:t>
             </a:r>
           </a:p>
         </p:txBody>
@@ -6410,7 +6410,7 @@
               </a:defRPr>
             </a:pPr>
             <a:r>
-              <a:t>【请在此插入：Pytest 终端 146 项测试全绿通过截图 / 性能压测曲线图】</a:t>
+              <a:t>【请在此插入：Pytest 终端 147 项测试全绿通过截图 / Docker Compose 运行截图】</a:t>
             </a:r>
           </a:p>
         </p:txBody>
@@ -12331,7 +12331,7 @@
               </a:defRPr>
             </a:pPr>
             <a:r>
-              <a:t>智能体协同机制：5大领域智能体家族分工与全序事件总线</a:t>
+              <a:t>智能体协同机制：5大智能体家族与对等信箱磋商 (Teammate Mailbox)</a:t>
             </a:r>
           </a:p>
         </p:txBody>
@@ -12428,7 +12428,7 @@
               </a:defRPr>
             </a:pPr>
             <a:r>
-              <a:t>用户意图分析 · 任务分解编排 · 并发调度驱动 · 响应聚合播报</a:t>
+              <a:t>用户意图分析 · 任务分解编排 · 并发调度驱动 · 实时心智流显像</a:t>
             </a:r>
           </a:p>
         </p:txBody>
@@ -12913,7 +12913,7 @@
               </a:defRPr>
             </a:pPr>
             <a:r>
-              <a:t>【请在此插入：5大智能体拓扑协同交互图 / 微内核全序事件总线架构图】</a:t>
+              <a:t>【请在此插入：Teammate Mailbox 对等信箱通信拓扑图 / 实时心智流前端显像截图】</a:t>
             </a:r>
           </a:p>
         </p:txBody>

</xml_diff>